<commit_message>
deck+docs: geometry-fix payoff slide + README v3.4.5-geo note
- deck: new 'closing the reconciliation loop' slide (15 slides now) —
  the reconciliation queue turned into action: 18 stale map lines found,
  15 redrawn (endpoint pins were the defect, not OSRM), 3 honest holdouts;
  acceptance method (re-anchor termini → OSRM → verified km band). QA'd
  via COM render.
- README: geometry-fix row in the pipeline table + a headline-results
  bullet; both point to the engine-side fix_geometries_v345geo scripts.

Co-Authored-By: Claude Opus 4.8 <noreply@anthropic.com>
</commit_message>
<xml_diff>
--- a/Bus_Sathi_Trace_Intelligence_Briefing.pptx
+++ b/Bus_Sathi_Trace_Intelligence_Briefing.pptx
@@ -19,6 +19,7 @@
     <p:sldId id="267" r:id="rId18"/>
     <p:sldId id="268" r:id="rId19"/>
     <p:sldId id="269" r:id="rId20"/>
+    <p:sldId id="270" r:id="rId21"/>
   </p:sldIdLst>
   <p:sldSz cx="12191695" cy="6858000" type="screen4x3"/>
   <p:notesSz cx="6858000" cy="9144000"/>
@@ -5996,6 +5997,575 @@
             <a:avLst/>
           </a:prstGeom>
           <a:solidFill>
+            <a:srgbClr val="FFFFFF"/>
+          </a:solidFill>
+          <a:ln>
+            <a:noFill/>
+          </a:ln>
+          <a:effectLst/>
+        </p:spPr>
+        <p:style>
+          <a:lnRef idx="1">
+            <a:schemeClr val="accent1"/>
+          </a:lnRef>
+          <a:fillRef idx="3">
+            <a:schemeClr val="accent1"/>
+          </a:fillRef>
+          <a:effectRef idx="2">
+            <a:schemeClr val="accent1"/>
+          </a:effectRef>
+          <a:fontRef idx="minor">
+            <a:schemeClr val="lt1"/>
+          </a:fontRef>
+        </p:style>
+        <p:txBody>
+          <a:bodyPr rtlCol="0" anchor="ctr"/>
+          <a:lstStyle/>
+          <a:p>
+            <a:pPr algn="ctr"/>
+          </a:p>
+        </p:txBody>
+      </p:sp>
+      <p:sp>
+        <p:nvSpPr>
+          <p:cNvPr id="3" name="TextBox 2"/>
+          <p:cNvSpPr txBox="1"/>
+          <p:nvPr/>
+        </p:nvSpPr>
+        <p:spPr>
+          <a:xfrm>
+            <a:off x="502920" y="292608"/>
+            <a:ext cx="11155680" cy="1188720"/>
+          </a:xfrm>
+          <a:prstGeom prst="rect">
+            <a:avLst/>
+          </a:prstGeom>
+          <a:noFill/>
+        </p:spPr>
+        <p:txBody>
+          <a:bodyPr wrap="square" lIns="0" rIns="0" tIns="0" bIns="0">
+            <a:spAutoFit/>
+          </a:bodyPr>
+          <a:lstStyle/>
+          <a:p>
+            <a:pPr algn="l">
+              <a:spcAft>
+                <a:spcPts val="400"/>
+              </a:spcAft>
+            </a:pPr>
+            <a:r>
+              <a:rPr sz="1200" b="1" i="0">
+                <a:solidFill>
+                  <a:srgbClr val="0F6E56"/>
+                </a:solidFill>
+                <a:latin typeface="Calibri"/>
+              </a:rPr>
+              <a:t>CLOSING THE RECONCILIATION LOOP</a:t>
+            </a:r>
+          </a:p>
+          <a:p>
+            <a:pPr algn="l">
+              <a:spcAft>
+                <a:spcPts val="200"/>
+              </a:spcAft>
+            </a:pPr>
+            <a:r>
+              <a:rPr sz="3100" b="1" i="0">
+                <a:solidFill>
+                  <a:srgbClr val="102A2E"/>
+                </a:solidFill>
+                <a:latin typeface="Cambria"/>
+              </a:rPr>
+              <a:t>Real driven paths fixed the plan's map lines</a:t>
+            </a:r>
+          </a:p>
+          <a:p>
+            <a:pPr algn="l">
+              <a:spcAft>
+                <a:spcPts val="0"/>
+              </a:spcAft>
+            </a:pPr>
+            <a:r>
+              <a:rPr sz="1300" b="0" i="0">
+                <a:solidFill>
+                  <a:srgbClr val="5B6B6B"/>
+                </a:solidFill>
+                <a:latin typeface="Calibri"/>
+              </a:rPr>
+              <a:t>The plan's distances were corrected earlier, but 18 route map lines still traced a path nobody certified — the endpoint pins were wrong.</a:t>
+            </a:r>
+          </a:p>
+        </p:txBody>
+      </p:sp>
+      <p:sp>
+        <p:nvSpPr>
+          <p:cNvPr id="4" name="Rounded Rectangle 3"/>
+          <p:cNvSpPr/>
+          <p:nvPr/>
+        </p:nvSpPr>
+        <p:spPr>
+          <a:xfrm>
+            <a:off x="502920" y="1737360"/>
+            <a:ext cx="3291840" cy="1481328"/>
+          </a:xfrm>
+          <a:prstGeom prst="roundRect">
+            <a:avLst>
+              <a:gd name="adj" fmla="val 6000"/>
+            </a:avLst>
+          </a:prstGeom>
+          <a:solidFill>
+            <a:srgbClr val="E9F2EE"/>
+          </a:solidFill>
+          <a:ln>
+            <a:noFill/>
+          </a:ln>
+          <a:effectLst/>
+        </p:spPr>
+        <p:style>
+          <a:lnRef idx="1">
+            <a:schemeClr val="accent1"/>
+          </a:lnRef>
+          <a:fillRef idx="3">
+            <a:schemeClr val="accent1"/>
+          </a:fillRef>
+          <a:effectRef idx="2">
+            <a:schemeClr val="accent1"/>
+          </a:effectRef>
+          <a:fontRef idx="minor">
+            <a:schemeClr val="lt1"/>
+          </a:fontRef>
+        </p:style>
+        <p:txBody>
+          <a:bodyPr rtlCol="0" anchor="ctr"/>
+          <a:lstStyle/>
+          <a:p>
+            <a:pPr algn="ctr"/>
+          </a:p>
+        </p:txBody>
+      </p:sp>
+      <p:sp>
+        <p:nvSpPr>
+          <p:cNvPr id="5" name="TextBox 4"/>
+          <p:cNvSpPr txBox="1"/>
+          <p:nvPr/>
+        </p:nvSpPr>
+        <p:spPr>
+          <a:xfrm>
+            <a:off x="667512" y="1865376"/>
+            <a:ext cx="2962656" cy="1243584"/>
+          </a:xfrm>
+          <a:prstGeom prst="rect">
+            <a:avLst/>
+          </a:prstGeom>
+          <a:noFill/>
+        </p:spPr>
+        <p:txBody>
+          <a:bodyPr wrap="square" lIns="0" rIns="0" tIns="0" bIns="0">
+            <a:spAutoFit/>
+          </a:bodyPr>
+          <a:lstStyle/>
+          <a:p>
+            <a:pPr algn="l">
+              <a:spcAft>
+                <a:spcPts val="400"/>
+              </a:spcAft>
+            </a:pPr>
+            <a:r>
+              <a:rPr sz="3000" b="1" i="0">
+                <a:solidFill>
+                  <a:srgbClr val="0F6E56"/>
+                </a:solidFill>
+                <a:latin typeface="Cambria"/>
+              </a:rPr>
+              <a:t>18</a:t>
+            </a:r>
+          </a:p>
+          <a:p>
+            <a:pPr algn="l">
+              <a:spcAft>
+                <a:spcPts val="400"/>
+              </a:spcAft>
+            </a:pPr>
+            <a:r>
+              <a:rPr sz="1250" b="1" i="0">
+                <a:solidFill>
+                  <a:srgbClr val="102A2E"/>
+                </a:solidFill>
+                <a:latin typeface="Calibri"/>
+              </a:rPr>
+              <a:t>stale map lines found</a:t>
+            </a:r>
+          </a:p>
+          <a:p>
+            <a:pPr algn="l">
+              <a:spcAft>
+                <a:spcPts val="0"/>
+              </a:spcAft>
+            </a:pPr>
+            <a:r>
+              <a:rPr sz="1000" b="0" i="0">
+                <a:solidFill>
+                  <a:srgbClr val="5B6B6B"/>
+                </a:solidFill>
+                <a:latin typeface="Calibri"/>
+              </a:rPr>
+              <a:t>drawn line &gt;25% longer than the corrected km</a:t>
+            </a:r>
+          </a:p>
+        </p:txBody>
+      </p:sp>
+      <p:sp>
+        <p:nvSpPr>
+          <p:cNvPr id="6" name="Rounded Rectangle 5"/>
+          <p:cNvSpPr/>
+          <p:nvPr/>
+        </p:nvSpPr>
+        <p:spPr>
+          <a:xfrm>
+            <a:off x="3977639" y="1737360"/>
+            <a:ext cx="3291840" cy="1481328"/>
+          </a:xfrm>
+          <a:prstGeom prst="roundRect">
+            <a:avLst>
+              <a:gd name="adj" fmla="val 6000"/>
+            </a:avLst>
+          </a:prstGeom>
+          <a:solidFill>
+            <a:srgbClr val="E9F2EE"/>
+          </a:solidFill>
+          <a:ln>
+            <a:noFill/>
+          </a:ln>
+          <a:effectLst/>
+        </p:spPr>
+        <p:style>
+          <a:lnRef idx="1">
+            <a:schemeClr val="accent1"/>
+          </a:lnRef>
+          <a:fillRef idx="3">
+            <a:schemeClr val="accent1"/>
+          </a:fillRef>
+          <a:effectRef idx="2">
+            <a:schemeClr val="accent1"/>
+          </a:effectRef>
+          <a:fontRef idx="minor">
+            <a:schemeClr val="lt1"/>
+          </a:fontRef>
+        </p:style>
+        <p:txBody>
+          <a:bodyPr rtlCol="0" anchor="ctr"/>
+          <a:lstStyle/>
+          <a:p>
+            <a:pPr algn="ctr"/>
+          </a:p>
+        </p:txBody>
+      </p:sp>
+      <p:sp>
+        <p:nvSpPr>
+          <p:cNvPr id="7" name="TextBox 6"/>
+          <p:cNvSpPr txBox="1"/>
+          <p:nvPr/>
+        </p:nvSpPr>
+        <p:spPr>
+          <a:xfrm>
+            <a:off x="4142231" y="1865376"/>
+            <a:ext cx="2962656" cy="1243584"/>
+          </a:xfrm>
+          <a:prstGeom prst="rect">
+            <a:avLst/>
+          </a:prstGeom>
+          <a:noFill/>
+        </p:spPr>
+        <p:txBody>
+          <a:bodyPr wrap="square" lIns="0" rIns="0" tIns="0" bIns="0">
+            <a:spAutoFit/>
+          </a:bodyPr>
+          <a:lstStyle/>
+          <a:p>
+            <a:pPr algn="l">
+              <a:spcAft>
+                <a:spcPts val="400"/>
+              </a:spcAft>
+            </a:pPr>
+            <a:r>
+              <a:rPr sz="3000" b="1" i="0">
+                <a:solidFill>
+                  <a:srgbClr val="0F6E56"/>
+                </a:solidFill>
+                <a:latin typeface="Cambria"/>
+              </a:rPr>
+              <a:t>15</a:t>
+            </a:r>
+          </a:p>
+          <a:p>
+            <a:pPr algn="l">
+              <a:spcAft>
+                <a:spcPts val="400"/>
+              </a:spcAft>
+            </a:pPr>
+            <a:r>
+              <a:rPr sz="1250" b="1" i="0">
+                <a:solidFill>
+                  <a:srgbClr val="102A2E"/>
+                </a:solidFill>
+                <a:latin typeface="Calibri"/>
+              </a:rPr>
+              <a:t>geometries redrawn</a:t>
+            </a:r>
+          </a:p>
+          <a:p>
+            <a:pPr algn="l">
+              <a:spcAft>
+                <a:spcPts val="0"/>
+              </a:spcAft>
+            </a:pPr>
+            <a:r>
+              <a:rPr sz="1000" b="0" i="0">
+                <a:solidFill>
+                  <a:srgbClr val="5B6B6B"/>
+                </a:solidFill>
+                <a:latin typeface="Calibri"/>
+              </a:rPr>
+              <a:t>re-anchored termini → real road path, in km band</a:t>
+            </a:r>
+          </a:p>
+        </p:txBody>
+      </p:sp>
+      <p:sp>
+        <p:nvSpPr>
+          <p:cNvPr id="8" name="Rounded Rectangle 7"/>
+          <p:cNvSpPr/>
+          <p:nvPr/>
+        </p:nvSpPr>
+        <p:spPr>
+          <a:xfrm>
+            <a:off x="502920" y="3383280"/>
+            <a:ext cx="3291840" cy="1481328"/>
+          </a:xfrm>
+          <a:prstGeom prst="roundRect">
+            <a:avLst>
+              <a:gd name="adj" fmla="val 6000"/>
+            </a:avLst>
+          </a:prstGeom>
+          <a:solidFill>
+            <a:srgbClr val="E9F2EE"/>
+          </a:solidFill>
+          <a:ln>
+            <a:noFill/>
+          </a:ln>
+          <a:effectLst/>
+        </p:spPr>
+        <p:style>
+          <a:lnRef idx="1">
+            <a:schemeClr val="accent1"/>
+          </a:lnRef>
+          <a:fillRef idx="3">
+            <a:schemeClr val="accent1"/>
+          </a:fillRef>
+          <a:effectRef idx="2">
+            <a:schemeClr val="accent1"/>
+          </a:effectRef>
+          <a:fontRef idx="minor">
+            <a:schemeClr val="lt1"/>
+          </a:fontRef>
+        </p:style>
+        <p:txBody>
+          <a:bodyPr rtlCol="0" anchor="ctr"/>
+          <a:lstStyle/>
+          <a:p>
+            <a:pPr algn="ctr"/>
+          </a:p>
+        </p:txBody>
+      </p:sp>
+      <p:sp>
+        <p:nvSpPr>
+          <p:cNvPr id="9" name="TextBox 8"/>
+          <p:cNvSpPr txBox="1"/>
+          <p:nvPr/>
+        </p:nvSpPr>
+        <p:spPr>
+          <a:xfrm>
+            <a:off x="667512" y="3511296"/>
+            <a:ext cx="2962656" cy="1243584"/>
+          </a:xfrm>
+          <a:prstGeom prst="rect">
+            <a:avLst/>
+          </a:prstGeom>
+          <a:noFill/>
+        </p:spPr>
+        <p:txBody>
+          <a:bodyPr wrap="square" lIns="0" rIns="0" tIns="0" bIns="0">
+            <a:spAutoFit/>
+          </a:bodyPr>
+          <a:lstStyle/>
+          <a:p>
+            <a:pPr algn="l">
+              <a:spcAft>
+                <a:spcPts val="400"/>
+              </a:spcAft>
+            </a:pPr>
+            <a:r>
+              <a:rPr sz="3000" b="1" i="0">
+                <a:solidFill>
+                  <a:srgbClr val="0F6E56"/>
+                </a:solidFill>
+                <a:latin typeface="Cambria"/>
+              </a:rPr>
+              <a:t>3</a:t>
+            </a:r>
+          </a:p>
+          <a:p>
+            <a:pPr algn="l">
+              <a:spcAft>
+                <a:spcPts val="400"/>
+              </a:spcAft>
+            </a:pPr>
+            <a:r>
+              <a:rPr sz="1250" b="1" i="0">
+                <a:solidFill>
+                  <a:srgbClr val="102A2E"/>
+                </a:solidFill>
+                <a:latin typeface="Calibri"/>
+              </a:rPr>
+              <a:t>honest holdouts</a:t>
+            </a:r>
+          </a:p>
+          <a:p>
+            <a:pPr algn="l">
+              <a:spcAft>
+                <a:spcPts val="0"/>
+              </a:spcAft>
+            </a:pPr>
+            <a:r>
+              <a:rPr sz="1000" b="0" i="0">
+                <a:solidFill>
+                  <a:srgbClr val="5B6B6B"/>
+                </a:solidFill>
+                <a:latin typeface="Calibri"/>
+              </a:rPr>
+              <a:t>one-way systems — flagged, not guessed</a:t>
+            </a:r>
+          </a:p>
+        </p:txBody>
+      </p:sp>
+      <p:sp>
+        <p:nvSpPr>
+          <p:cNvPr id="10" name="Rounded Rectangle 9"/>
+          <p:cNvSpPr/>
+          <p:nvPr/>
+        </p:nvSpPr>
+        <p:spPr>
+          <a:xfrm>
+            <a:off x="3977639" y="3383280"/>
+            <a:ext cx="3291840" cy="1463040"/>
+          </a:xfrm>
+          <a:prstGeom prst="roundRect">
+            <a:avLst>
+              <a:gd name="adj" fmla="val 6000"/>
+            </a:avLst>
+          </a:prstGeom>
+          <a:solidFill>
+            <a:srgbClr val="E9F2EE"/>
+          </a:solidFill>
+          <a:ln>
+            <a:noFill/>
+          </a:ln>
+          <a:effectLst/>
+        </p:spPr>
+        <p:style>
+          <a:lnRef idx="1">
+            <a:schemeClr val="accent1"/>
+          </a:lnRef>
+          <a:fillRef idx="3">
+            <a:schemeClr val="accent1"/>
+          </a:fillRef>
+          <a:effectRef idx="2">
+            <a:schemeClr val="accent1"/>
+          </a:effectRef>
+          <a:fontRef idx="minor">
+            <a:schemeClr val="lt1"/>
+          </a:fontRef>
+        </p:style>
+        <p:txBody>
+          <a:bodyPr rtlCol="0" anchor="ctr"/>
+          <a:lstStyle/>
+          <a:p>
+            <a:pPr algn="ctr"/>
+          </a:p>
+        </p:txBody>
+      </p:sp>
+      <p:sp>
+        <p:nvSpPr>
+          <p:cNvPr id="11" name="TextBox 10"/>
+          <p:cNvSpPr txBox="1"/>
+          <p:nvPr/>
+        </p:nvSpPr>
+        <p:spPr>
+          <a:xfrm>
+            <a:off x="4206240" y="3547872"/>
+            <a:ext cx="2834640" cy="1188720"/>
+          </a:xfrm>
+          <a:prstGeom prst="rect">
+            <a:avLst/>
+          </a:prstGeom>
+          <a:noFill/>
+        </p:spPr>
+        <p:txBody>
+          <a:bodyPr wrap="square" lIns="0" rIns="0" tIns="0" bIns="0">
+            <a:spAutoFit/>
+          </a:bodyPr>
+          <a:lstStyle/>
+          <a:p>
+            <a:pPr algn="l">
+              <a:spcAft>
+                <a:spcPts val="200"/>
+              </a:spcAft>
+            </a:pPr>
+            <a:r>
+              <a:rPr sz="1250" b="1" i="0">
+                <a:solidFill>
+                  <a:srgbClr val="0F6E56"/>
+                </a:solidFill>
+                <a:latin typeface="Cambria"/>
+              </a:rPr>
+              <a:t>The tell</a:t>
+            </a:r>
+          </a:p>
+          <a:p>
+            <a:pPr algn="l">
+              <a:spcAft>
+                <a:spcPts val="0"/>
+              </a:spcAft>
+            </a:pPr>
+            <a:r>
+              <a:rPr sz="1100" b="0" i="0">
+                <a:solidFill>
+                  <a:srgbClr val="102A2E"/>
+                </a:solidFill>
+                <a:latin typeface="Calibri"/>
+              </a:rPr>
+              <a:t>Every stale line WAS OSRM's shortest path from its pins — so the pins were the defect, not the routing.</a:t>
+            </a:r>
+          </a:p>
+        </p:txBody>
+      </p:sp>
+      <p:sp>
+        <p:nvSpPr>
+          <p:cNvPr id="12" name="Rounded Rectangle 11"/>
+          <p:cNvSpPr/>
+          <p:nvPr/>
+        </p:nvSpPr>
+        <p:spPr>
+          <a:xfrm>
+            <a:off x="502920" y="5029200"/>
+            <a:ext cx="11155680" cy="1371600"/>
+          </a:xfrm>
+          <a:prstGeom prst="roundRect">
+            <a:avLst>
+              <a:gd name="adj" fmla="val 6000"/>
+            </a:avLst>
+          </a:prstGeom>
+          <a:solidFill>
             <a:srgbClr val="0A3D33"/>
           </a:solidFill>
           <a:ln>
@@ -6027,14 +6597,14 @@
       </p:sp>
       <p:sp>
         <p:nvSpPr>
-          <p:cNvPr id="3" name="TextBox 2"/>
+          <p:cNvPr id="13" name="TextBox 12"/>
           <p:cNvSpPr txBox="1"/>
           <p:nvPr/>
         </p:nvSpPr>
         <p:spPr>
           <a:xfrm>
-            <a:off x="502920" y="365760"/>
-            <a:ext cx="11155680" cy="1005840"/>
+            <a:off x="777240" y="5193792"/>
+            <a:ext cx="10607040" cy="1097280"/>
           </a:xfrm>
           <a:prstGeom prst="rect">
             <a:avLst/>
@@ -6049,118 +6619,17 @@
           <a:p>
             <a:pPr algn="l">
               <a:spcAft>
-                <a:spcPts val="400"/>
-              </a:spcAft>
-            </a:pPr>
-            <a:r>
-              <a:rPr sz="1200" b="1" i="0">
-                <a:solidFill>
-                  <a:srgbClr val="7FC8AF"/>
-                </a:solidFill>
-                <a:latin typeface="Calibri"/>
-              </a:rPr>
-              <a:t>READ BEFORE CITING</a:t>
-            </a:r>
-          </a:p>
-          <a:p>
-            <a:pPr algn="l">
-              <a:spcAft>
-                <a:spcPts val="200"/>
-              </a:spcAft>
-            </a:pPr>
-            <a:r>
-              <a:rPr sz="3100" b="1" i="0">
+                <a:spcPts val="300"/>
+              </a:spcAft>
+            </a:pPr>
+            <a:r>
+              <a:rPr sz="1250" b="1" i="0">
                 <a:solidFill>
                   <a:srgbClr val="FFFFFF"/>
                 </a:solidFill>
                 <a:latin typeface="Cambria"/>
               </a:rPr>
-              <a:t>What this data cannot tell us</a:t>
-            </a:r>
-          </a:p>
-        </p:txBody>
-      </p:sp>
-      <p:sp>
-        <p:nvSpPr>
-          <p:cNvPr id="4" name="Rounded Rectangle 3"/>
-          <p:cNvSpPr/>
-          <p:nvPr/>
-        </p:nvSpPr>
-        <p:spPr>
-          <a:xfrm>
-            <a:off x="502920" y="1600200"/>
-            <a:ext cx="11155680" cy="841248"/>
-          </a:xfrm>
-          <a:prstGeom prst="roundRect">
-            <a:avLst>
-              <a:gd name="adj" fmla="val 6000"/>
-            </a:avLst>
-          </a:prstGeom>
-          <a:solidFill>
-            <a:srgbClr val="0E4A3E"/>
-          </a:solidFill>
-          <a:ln>
-            <a:noFill/>
-          </a:ln>
-          <a:effectLst/>
-        </p:spPr>
-        <p:style>
-          <a:lnRef idx="1">
-            <a:schemeClr val="accent1"/>
-          </a:lnRef>
-          <a:fillRef idx="3">
-            <a:schemeClr val="accent1"/>
-          </a:fillRef>
-          <a:effectRef idx="2">
-            <a:schemeClr val="accent1"/>
-          </a:effectRef>
-          <a:fontRef idx="minor">
-            <a:schemeClr val="lt1"/>
-          </a:fontRef>
-        </p:style>
-        <p:txBody>
-          <a:bodyPr rtlCol="0" anchor="ctr"/>
-          <a:lstStyle/>
-          <a:p>
-            <a:pPr algn="ctr"/>
-          </a:p>
-        </p:txBody>
-      </p:sp>
-      <p:sp>
-        <p:nvSpPr>
-          <p:cNvPr id="5" name="TextBox 4"/>
-          <p:cNvSpPr txBox="1"/>
-          <p:nvPr/>
-        </p:nvSpPr>
-        <p:spPr>
-          <a:xfrm>
-            <a:off x="777240" y="1691640"/>
-            <a:ext cx="10607040" cy="676656"/>
-          </a:xfrm>
-          <a:prstGeom prst="rect">
-            <a:avLst/>
-          </a:prstGeom>
-          <a:noFill/>
-        </p:spPr>
-        <p:txBody>
-          <a:bodyPr wrap="square" lIns="0" rIns="0" tIns="0" bIns="0">
-            <a:spAutoFit/>
-          </a:bodyPr>
-          <a:lstStyle/>
-          <a:p>
-            <a:pPr algn="l">
-              <a:spcAft>
-                <a:spcPts val="100"/>
-              </a:spcAft>
-            </a:pPr>
-            <a:r>
-              <a:rPr sz="1350" b="1" i="0">
-                <a:solidFill>
-                  <a:srgbClr val="FFFFFF"/>
-                </a:solidFill>
-                <a:latin typeface="Calibri"/>
-              </a:rPr>
-              <a:t>Partial, self-selected adoption</a:t>
+              <a:t>How each fix was accepted</a:t>
             </a:r>
           </a:p>
           <a:p>
@@ -6172,415 +6641,11 @@
             <a:r>
               <a:rPr sz="1150" b="0" i="0">
                 <a:solidFill>
-                  <a:srgbClr val="C9E2D8"/>
-                </a:solidFill>
-                <a:latin typeface="Calibri"/>
-              </a:rPr>
-              <a:t>~157 active drivers, Srinagar-concentrated. “No app data on a route” does NOT mean “no service”.</a:t>
-            </a:r>
-          </a:p>
-        </p:txBody>
-      </p:sp>
-      <p:sp>
-        <p:nvSpPr>
-          <p:cNvPr id="6" name="Rounded Rectangle 5"/>
-          <p:cNvSpPr/>
-          <p:nvPr/>
-        </p:nvSpPr>
-        <p:spPr>
-          <a:xfrm>
-            <a:off x="502920" y="2569464"/>
-            <a:ext cx="11155680" cy="841248"/>
-          </a:xfrm>
-          <a:prstGeom prst="roundRect">
-            <a:avLst>
-              <a:gd name="adj" fmla="val 6000"/>
-            </a:avLst>
-          </a:prstGeom>
-          <a:solidFill>
-            <a:srgbClr val="0E4A3E"/>
-          </a:solidFill>
-          <a:ln>
-            <a:noFill/>
-          </a:ln>
-          <a:effectLst/>
-        </p:spPr>
-        <p:style>
-          <a:lnRef idx="1">
-            <a:schemeClr val="accent1"/>
-          </a:lnRef>
-          <a:fillRef idx="3">
-            <a:schemeClr val="accent1"/>
-          </a:fillRef>
-          <a:effectRef idx="2">
-            <a:schemeClr val="accent1"/>
-          </a:effectRef>
-          <a:fontRef idx="minor">
-            <a:schemeClr val="lt1"/>
-          </a:fontRef>
-        </p:style>
-        <p:txBody>
-          <a:bodyPr rtlCol="0" anchor="ctr"/>
-          <a:lstStyle/>
-          <a:p>
-            <a:pPr algn="ctr"/>
-          </a:p>
-        </p:txBody>
-      </p:sp>
-      <p:sp>
-        <p:nvSpPr>
-          <p:cNvPr id="7" name="TextBox 6"/>
-          <p:cNvSpPr txBox="1"/>
-          <p:nvPr/>
-        </p:nvSpPr>
-        <p:spPr>
-          <a:xfrm>
-            <a:off x="777240" y="2660904"/>
-            <a:ext cx="10607040" cy="676656"/>
-          </a:xfrm>
-          <a:prstGeom prst="rect">
-            <a:avLst/>
-          </a:prstGeom>
-          <a:noFill/>
-        </p:spPr>
-        <p:txBody>
-          <a:bodyPr wrap="square" lIns="0" rIns="0" tIns="0" bIns="0">
-            <a:spAutoFit/>
-          </a:bodyPr>
-          <a:lstStyle/>
-          <a:p>
-            <a:pPr algn="l">
-              <a:spcAft>
-                <a:spcPts val="100"/>
-              </a:spcAft>
-            </a:pPr>
-            <a:r>
-              <a:rPr sz="1350" b="1" i="0">
-                <a:solidFill>
-                  <a:srgbClr val="FFFFFF"/>
-                </a:solidFill>
-                <a:latin typeface="Calibri"/>
-              </a:rPr>
-              <a:t>No demand, no ridership, no frequency</a:t>
-            </a:r>
-          </a:p>
-          <a:p>
-            <a:pPr algn="l">
-              <a:spcAft>
-                <a:spcPts val="0"/>
-              </a:spcAft>
-            </a:pPr>
-            <a:r>
-              <a:rPr sz="1150" b="0" i="0">
-                <a:solidFill>
-                  <a:srgbClr val="C9E2D8"/>
-                </a:solidFill>
-                <a:latin typeface="Calibri"/>
-              </a:rPr>
-              <a:t>The app sees vehicles, not passengers. Observed run counts reflect who installed the app — never cited as service frequency.</a:t>
-            </a:r>
-          </a:p>
-        </p:txBody>
-      </p:sp>
-      <p:sp>
-        <p:nvSpPr>
-          <p:cNvPr id="8" name="Rounded Rectangle 7"/>
-          <p:cNvSpPr/>
-          <p:nvPr/>
-        </p:nvSpPr>
-        <p:spPr>
-          <a:xfrm>
-            <a:off x="502920" y="3538728"/>
-            <a:ext cx="11155680" cy="841248"/>
-          </a:xfrm>
-          <a:prstGeom prst="roundRect">
-            <a:avLst>
-              <a:gd name="adj" fmla="val 6000"/>
-            </a:avLst>
-          </a:prstGeom>
-          <a:solidFill>
-            <a:srgbClr val="0E4A3E"/>
-          </a:solidFill>
-          <a:ln>
-            <a:noFill/>
-          </a:ln>
-          <a:effectLst/>
-        </p:spPr>
-        <p:style>
-          <a:lnRef idx="1">
-            <a:schemeClr val="accent1"/>
-          </a:lnRef>
-          <a:fillRef idx="3">
-            <a:schemeClr val="accent1"/>
-          </a:fillRef>
-          <a:effectRef idx="2">
-            <a:schemeClr val="accent1"/>
-          </a:effectRef>
-          <a:fontRef idx="minor">
-            <a:schemeClr val="lt1"/>
-          </a:fontRef>
-        </p:style>
-        <p:txBody>
-          <a:bodyPr rtlCol="0" anchor="ctr"/>
-          <a:lstStyle/>
-          <a:p>
-            <a:pPr algn="ctr"/>
-          </a:p>
-        </p:txBody>
-      </p:sp>
-      <p:sp>
-        <p:nvSpPr>
-          <p:cNvPr id="9" name="TextBox 8"/>
-          <p:cNvSpPr txBox="1"/>
-          <p:nvPr/>
-        </p:nvSpPr>
-        <p:spPr>
-          <a:xfrm>
-            <a:off x="777240" y="3630168"/>
-            <a:ext cx="10607040" cy="676656"/>
-          </a:xfrm>
-          <a:prstGeom prst="rect">
-            <a:avLst/>
-          </a:prstGeom>
-          <a:noFill/>
-        </p:spPr>
-        <p:txBody>
-          <a:bodyPr wrap="square" lIns="0" rIns="0" tIns="0" bIns="0">
-            <a:spAutoFit/>
-          </a:bodyPr>
-          <a:lstStyle/>
-          <a:p>
-            <a:pPr algn="l">
-              <a:spcAft>
-                <a:spcPts val="100"/>
-              </a:spcAft>
-            </a:pPr>
-            <a:r>
-              <a:rPr sz="1350" b="1" i="0">
-                <a:solidFill>
-                  <a:srgbClr val="FFFFFF"/>
-                </a:solidFill>
-                <a:latin typeface="Calibri"/>
-              </a:rPr>
-              <a:t>Corridors cover 41% of clean runs</a:t>
-            </a:r>
-          </a:p>
-          <a:p>
-            <a:pPr algn="l">
-              <a:spcAft>
-                <a:spcPts val="0"/>
-              </a:spcAft>
-            </a:pPr>
-            <a:r>
-              <a:rPr sz="1150" b="0" i="0">
-                <a:solidFill>
-                  <a:srgbClr val="C9E2D8"/>
-                </a:solidFill>
-                <a:latin typeface="Calibri"/>
-              </a:rPr>
-              <a:t>The other 59% was decomposed and shown to be noise, loops and out-of-division traffic — but the corridor findings describe the frequently-driven core only.</a:t>
-            </a:r>
-          </a:p>
-        </p:txBody>
-      </p:sp>
-      <p:sp>
-        <p:nvSpPr>
-          <p:cNvPr id="10" name="Rounded Rectangle 9"/>
-          <p:cNvSpPr/>
-          <p:nvPr/>
-        </p:nvSpPr>
-        <p:spPr>
-          <a:xfrm>
-            <a:off x="502920" y="4507992"/>
-            <a:ext cx="11155680" cy="841248"/>
-          </a:xfrm>
-          <a:prstGeom prst="roundRect">
-            <a:avLst>
-              <a:gd name="adj" fmla="val 6000"/>
-            </a:avLst>
-          </a:prstGeom>
-          <a:solidFill>
-            <a:srgbClr val="0E4A3E"/>
-          </a:solidFill>
-          <a:ln>
-            <a:noFill/>
-          </a:ln>
-          <a:effectLst/>
-        </p:spPr>
-        <p:style>
-          <a:lnRef idx="1">
-            <a:schemeClr val="accent1"/>
-          </a:lnRef>
-          <a:fillRef idx="3">
-            <a:schemeClr val="accent1"/>
-          </a:fillRef>
-          <a:effectRef idx="2">
-            <a:schemeClr val="accent1"/>
-          </a:effectRef>
-          <a:fontRef idx="minor">
-            <a:schemeClr val="lt1"/>
-          </a:fontRef>
-        </p:style>
-        <p:txBody>
-          <a:bodyPr rtlCol="0" anchor="ctr"/>
-          <a:lstStyle/>
-          <a:p>
-            <a:pPr algn="ctr"/>
-          </a:p>
-        </p:txBody>
-      </p:sp>
-      <p:sp>
-        <p:nvSpPr>
-          <p:cNvPr id="11" name="TextBox 10"/>
-          <p:cNvSpPr txBox="1"/>
-          <p:nvPr/>
-        </p:nvSpPr>
-        <p:spPr>
-          <a:xfrm>
-            <a:off x="777240" y="4599431"/>
-            <a:ext cx="10607040" cy="676656"/>
-          </a:xfrm>
-          <a:prstGeom prst="rect">
-            <a:avLst/>
-          </a:prstGeom>
-          <a:noFill/>
-        </p:spPr>
-        <p:txBody>
-          <a:bodyPr wrap="square" lIns="0" rIns="0" tIns="0" bIns="0">
-            <a:spAutoFit/>
-          </a:bodyPr>
-          <a:lstStyle/>
-          <a:p>
-            <a:pPr algn="l">
-              <a:spcAft>
-                <a:spcPts val="100"/>
-              </a:spcAft>
-            </a:pPr>
-            <a:r>
-              <a:rPr sz="1350" b="1" i="0">
-                <a:solidFill>
-                  <a:srgbClr val="FFFFFF"/>
-                </a:solidFill>
-                <a:latin typeface="Calibri"/>
-              </a:rPr>
-              <a:t>Observed times are an upper bound</a:t>
-            </a:r>
-          </a:p>
-          <a:p>
-            <a:pPr algn="l">
-              <a:spcAft>
-                <a:spcPts val="0"/>
-              </a:spcAft>
-            </a:pPr>
-            <a:r>
-              <a:rPr sz="1150" b="0" i="0">
-                <a:solidFill>
-                  <a:srgbClr val="C9E2D8"/>
-                </a:solidFill>
-                <a:latin typeface="Calibri"/>
-              </a:rPr>
-              <a:t>They embody informal wait-to-fill practice; a scheduled, headway-enforced service should beat them.</a:t>
-            </a:r>
-          </a:p>
-        </p:txBody>
-      </p:sp>
-      <p:sp>
-        <p:nvSpPr>
-          <p:cNvPr id="12" name="Rounded Rectangle 11"/>
-          <p:cNvSpPr/>
-          <p:nvPr/>
-        </p:nvSpPr>
-        <p:spPr>
-          <a:xfrm>
-            <a:off x="502920" y="5477256"/>
-            <a:ext cx="11155680" cy="841248"/>
-          </a:xfrm>
-          <a:prstGeom prst="roundRect">
-            <a:avLst>
-              <a:gd name="adj" fmla="val 6000"/>
-            </a:avLst>
-          </a:prstGeom>
-          <a:solidFill>
-            <a:srgbClr val="0E4A3E"/>
-          </a:solidFill>
-          <a:ln>
-            <a:noFill/>
-          </a:ln>
-          <a:effectLst/>
-        </p:spPr>
-        <p:style>
-          <a:lnRef idx="1">
-            <a:schemeClr val="accent1"/>
-          </a:lnRef>
-          <a:fillRef idx="3">
-            <a:schemeClr val="accent1"/>
-          </a:fillRef>
-          <a:effectRef idx="2">
-            <a:schemeClr val="accent1"/>
-          </a:effectRef>
-          <a:fontRef idx="minor">
-            <a:schemeClr val="lt1"/>
-          </a:fontRef>
-        </p:style>
-        <p:txBody>
-          <a:bodyPr rtlCol="0" anchor="ctr"/>
-          <a:lstStyle/>
-          <a:p>
-            <a:pPr algn="ctr"/>
-          </a:p>
-        </p:txBody>
-      </p:sp>
-      <p:sp>
-        <p:nvSpPr>
-          <p:cNvPr id="13" name="TextBox 12"/>
-          <p:cNvSpPr txBox="1"/>
-          <p:nvPr/>
-        </p:nvSpPr>
-        <p:spPr>
-          <a:xfrm>
-            <a:off x="777240" y="5568696"/>
-            <a:ext cx="10607040" cy="676656"/>
-          </a:xfrm>
-          <a:prstGeom prst="rect">
-            <a:avLst/>
-          </a:prstGeom>
-          <a:noFill/>
-        </p:spPr>
-        <p:txBody>
-          <a:bodyPr wrap="square" lIns="0" rIns="0" tIns="0" bIns="0">
-            <a:spAutoFit/>
-          </a:bodyPr>
-          <a:lstStyle/>
-          <a:p>
-            <a:pPr algn="l">
-              <a:spcAft>
-                <a:spcPts val="100"/>
-              </a:spcAft>
-            </a:pPr>
-            <a:r>
-              <a:rPr sz="1350" b="1" i="0">
-                <a:solidFill>
-                  <a:srgbClr val="FFFFFF"/>
-                </a:solidFill>
-                <a:latin typeface="Calibri"/>
-              </a:rPr>
-              <a:t>Rural routes remain unvalidated</a:t>
-            </a:r>
-          </a:p>
-          <a:p>
-            <a:pPr algn="l">
-              <a:spcAft>
-                <a:spcPts val="0"/>
-              </a:spcAft>
-            </a:pPr>
-            <a:r>
-              <a:rPr sz="1150" b="0" i="0">
-                <a:solidFill>
-                  <a:srgbClr val="C9E2D8"/>
-                </a:solidFill>
-                <a:latin typeface="Calibri"/>
-              </a:rPr>
-              <a:t>Measured corrections touch 5 Srinagar-core corridors; long rural lifeline cycle times still rest on the model.</a:t>
+                  <a:srgbClr val="D5E8DF"/>
+                </a:solidFill>
+                <a:latin typeface="Calibri"/>
+              </a:rPr>
+              <a:t>Re-anchor the termini (stops register · observed GPS stop clusters · researched pins — JVC = SKIMS Bemina; Iskanderpora &amp; Badran = Beerwah-belt Budgam villages) → OSRM re-route → accept ONLY inside the route's web-verified km band → prefer a real observed run between the pins. Numbers unchanged; only the geometry.</a:t>
             </a:r>
           </a:p>
         </p:txBody>
@@ -6594,6 +6659,628 @@
 </file>
 
 <file path=ppt/slides/slide14.xml><?xml version="1.0" encoding="utf-8"?>
+<p:sld xmlns:a="http://schemas.openxmlformats.org/drawingml/2006/main" xmlns:p="http://schemas.openxmlformats.org/presentationml/2006/main" xmlns:r="http://schemas.openxmlformats.org/officeDocument/2006/relationships">
+  <p:cSld>
+    <p:spTree>
+      <p:nvGrpSpPr>
+        <p:cNvPr id="1" name=""/>
+        <p:cNvGrpSpPr/>
+        <p:nvPr/>
+      </p:nvGrpSpPr>
+      <p:grpSpPr/>
+      <p:sp>
+        <p:nvSpPr>
+          <p:cNvPr id="2" name="Rectangle 1"/>
+          <p:cNvSpPr/>
+          <p:nvPr/>
+        </p:nvSpPr>
+        <p:spPr>
+          <a:xfrm>
+            <a:off x="0" y="0"/>
+            <a:ext cx="12191695" cy="6858000"/>
+          </a:xfrm>
+          <a:prstGeom prst="rect">
+            <a:avLst/>
+          </a:prstGeom>
+          <a:solidFill>
+            <a:srgbClr val="0A3D33"/>
+          </a:solidFill>
+          <a:ln>
+            <a:noFill/>
+          </a:ln>
+          <a:effectLst/>
+        </p:spPr>
+        <p:style>
+          <a:lnRef idx="1">
+            <a:schemeClr val="accent1"/>
+          </a:lnRef>
+          <a:fillRef idx="3">
+            <a:schemeClr val="accent1"/>
+          </a:fillRef>
+          <a:effectRef idx="2">
+            <a:schemeClr val="accent1"/>
+          </a:effectRef>
+          <a:fontRef idx="minor">
+            <a:schemeClr val="lt1"/>
+          </a:fontRef>
+        </p:style>
+        <p:txBody>
+          <a:bodyPr rtlCol="0" anchor="ctr"/>
+          <a:lstStyle/>
+          <a:p>
+            <a:pPr algn="ctr"/>
+          </a:p>
+        </p:txBody>
+      </p:sp>
+      <p:sp>
+        <p:nvSpPr>
+          <p:cNvPr id="3" name="TextBox 2"/>
+          <p:cNvSpPr txBox="1"/>
+          <p:nvPr/>
+        </p:nvSpPr>
+        <p:spPr>
+          <a:xfrm>
+            <a:off x="502920" y="365760"/>
+            <a:ext cx="11155680" cy="1005840"/>
+          </a:xfrm>
+          <a:prstGeom prst="rect">
+            <a:avLst/>
+          </a:prstGeom>
+          <a:noFill/>
+        </p:spPr>
+        <p:txBody>
+          <a:bodyPr wrap="square" lIns="0" rIns="0" tIns="0" bIns="0">
+            <a:spAutoFit/>
+          </a:bodyPr>
+          <a:lstStyle/>
+          <a:p>
+            <a:pPr algn="l">
+              <a:spcAft>
+                <a:spcPts val="400"/>
+              </a:spcAft>
+            </a:pPr>
+            <a:r>
+              <a:rPr sz="1200" b="1" i="0">
+                <a:solidFill>
+                  <a:srgbClr val="7FC8AF"/>
+                </a:solidFill>
+                <a:latin typeface="Calibri"/>
+              </a:rPr>
+              <a:t>READ BEFORE CITING</a:t>
+            </a:r>
+          </a:p>
+          <a:p>
+            <a:pPr algn="l">
+              <a:spcAft>
+                <a:spcPts val="200"/>
+              </a:spcAft>
+            </a:pPr>
+            <a:r>
+              <a:rPr sz="3100" b="1" i="0">
+                <a:solidFill>
+                  <a:srgbClr val="FFFFFF"/>
+                </a:solidFill>
+                <a:latin typeface="Cambria"/>
+              </a:rPr>
+              <a:t>What this data cannot tell us</a:t>
+            </a:r>
+          </a:p>
+        </p:txBody>
+      </p:sp>
+      <p:sp>
+        <p:nvSpPr>
+          <p:cNvPr id="4" name="Rounded Rectangle 3"/>
+          <p:cNvSpPr/>
+          <p:nvPr/>
+        </p:nvSpPr>
+        <p:spPr>
+          <a:xfrm>
+            <a:off x="502920" y="1600200"/>
+            <a:ext cx="11155680" cy="841248"/>
+          </a:xfrm>
+          <a:prstGeom prst="roundRect">
+            <a:avLst>
+              <a:gd name="adj" fmla="val 6000"/>
+            </a:avLst>
+          </a:prstGeom>
+          <a:solidFill>
+            <a:srgbClr val="0E4A3E"/>
+          </a:solidFill>
+          <a:ln>
+            <a:noFill/>
+          </a:ln>
+          <a:effectLst/>
+        </p:spPr>
+        <p:style>
+          <a:lnRef idx="1">
+            <a:schemeClr val="accent1"/>
+          </a:lnRef>
+          <a:fillRef idx="3">
+            <a:schemeClr val="accent1"/>
+          </a:fillRef>
+          <a:effectRef idx="2">
+            <a:schemeClr val="accent1"/>
+          </a:effectRef>
+          <a:fontRef idx="minor">
+            <a:schemeClr val="lt1"/>
+          </a:fontRef>
+        </p:style>
+        <p:txBody>
+          <a:bodyPr rtlCol="0" anchor="ctr"/>
+          <a:lstStyle/>
+          <a:p>
+            <a:pPr algn="ctr"/>
+          </a:p>
+        </p:txBody>
+      </p:sp>
+      <p:sp>
+        <p:nvSpPr>
+          <p:cNvPr id="5" name="TextBox 4"/>
+          <p:cNvSpPr txBox="1"/>
+          <p:nvPr/>
+        </p:nvSpPr>
+        <p:spPr>
+          <a:xfrm>
+            <a:off x="777240" y="1691640"/>
+            <a:ext cx="10607040" cy="676656"/>
+          </a:xfrm>
+          <a:prstGeom prst="rect">
+            <a:avLst/>
+          </a:prstGeom>
+          <a:noFill/>
+        </p:spPr>
+        <p:txBody>
+          <a:bodyPr wrap="square" lIns="0" rIns="0" tIns="0" bIns="0">
+            <a:spAutoFit/>
+          </a:bodyPr>
+          <a:lstStyle/>
+          <a:p>
+            <a:pPr algn="l">
+              <a:spcAft>
+                <a:spcPts val="100"/>
+              </a:spcAft>
+            </a:pPr>
+            <a:r>
+              <a:rPr sz="1350" b="1" i="0">
+                <a:solidFill>
+                  <a:srgbClr val="FFFFFF"/>
+                </a:solidFill>
+                <a:latin typeface="Calibri"/>
+              </a:rPr>
+              <a:t>Partial, self-selected adoption</a:t>
+            </a:r>
+          </a:p>
+          <a:p>
+            <a:pPr algn="l">
+              <a:spcAft>
+                <a:spcPts val="0"/>
+              </a:spcAft>
+            </a:pPr>
+            <a:r>
+              <a:rPr sz="1150" b="0" i="0">
+                <a:solidFill>
+                  <a:srgbClr val="C9E2D8"/>
+                </a:solidFill>
+                <a:latin typeface="Calibri"/>
+              </a:rPr>
+              <a:t>~157 active drivers, Srinagar-concentrated. “No app data on a route” does NOT mean “no service”.</a:t>
+            </a:r>
+          </a:p>
+        </p:txBody>
+      </p:sp>
+      <p:sp>
+        <p:nvSpPr>
+          <p:cNvPr id="6" name="Rounded Rectangle 5"/>
+          <p:cNvSpPr/>
+          <p:nvPr/>
+        </p:nvSpPr>
+        <p:spPr>
+          <a:xfrm>
+            <a:off x="502920" y="2569464"/>
+            <a:ext cx="11155680" cy="841248"/>
+          </a:xfrm>
+          <a:prstGeom prst="roundRect">
+            <a:avLst>
+              <a:gd name="adj" fmla="val 6000"/>
+            </a:avLst>
+          </a:prstGeom>
+          <a:solidFill>
+            <a:srgbClr val="0E4A3E"/>
+          </a:solidFill>
+          <a:ln>
+            <a:noFill/>
+          </a:ln>
+          <a:effectLst/>
+        </p:spPr>
+        <p:style>
+          <a:lnRef idx="1">
+            <a:schemeClr val="accent1"/>
+          </a:lnRef>
+          <a:fillRef idx="3">
+            <a:schemeClr val="accent1"/>
+          </a:fillRef>
+          <a:effectRef idx="2">
+            <a:schemeClr val="accent1"/>
+          </a:effectRef>
+          <a:fontRef idx="minor">
+            <a:schemeClr val="lt1"/>
+          </a:fontRef>
+        </p:style>
+        <p:txBody>
+          <a:bodyPr rtlCol="0" anchor="ctr"/>
+          <a:lstStyle/>
+          <a:p>
+            <a:pPr algn="ctr"/>
+          </a:p>
+        </p:txBody>
+      </p:sp>
+      <p:sp>
+        <p:nvSpPr>
+          <p:cNvPr id="7" name="TextBox 6"/>
+          <p:cNvSpPr txBox="1"/>
+          <p:nvPr/>
+        </p:nvSpPr>
+        <p:spPr>
+          <a:xfrm>
+            <a:off x="777240" y="2660904"/>
+            <a:ext cx="10607040" cy="676656"/>
+          </a:xfrm>
+          <a:prstGeom prst="rect">
+            <a:avLst/>
+          </a:prstGeom>
+          <a:noFill/>
+        </p:spPr>
+        <p:txBody>
+          <a:bodyPr wrap="square" lIns="0" rIns="0" tIns="0" bIns="0">
+            <a:spAutoFit/>
+          </a:bodyPr>
+          <a:lstStyle/>
+          <a:p>
+            <a:pPr algn="l">
+              <a:spcAft>
+                <a:spcPts val="100"/>
+              </a:spcAft>
+            </a:pPr>
+            <a:r>
+              <a:rPr sz="1350" b="1" i="0">
+                <a:solidFill>
+                  <a:srgbClr val="FFFFFF"/>
+                </a:solidFill>
+                <a:latin typeface="Calibri"/>
+              </a:rPr>
+              <a:t>No demand, no ridership, no frequency</a:t>
+            </a:r>
+          </a:p>
+          <a:p>
+            <a:pPr algn="l">
+              <a:spcAft>
+                <a:spcPts val="0"/>
+              </a:spcAft>
+            </a:pPr>
+            <a:r>
+              <a:rPr sz="1150" b="0" i="0">
+                <a:solidFill>
+                  <a:srgbClr val="C9E2D8"/>
+                </a:solidFill>
+                <a:latin typeface="Calibri"/>
+              </a:rPr>
+              <a:t>The app sees vehicles, not passengers. Observed run counts reflect who installed the app — never cited as service frequency.</a:t>
+            </a:r>
+          </a:p>
+        </p:txBody>
+      </p:sp>
+      <p:sp>
+        <p:nvSpPr>
+          <p:cNvPr id="8" name="Rounded Rectangle 7"/>
+          <p:cNvSpPr/>
+          <p:nvPr/>
+        </p:nvSpPr>
+        <p:spPr>
+          <a:xfrm>
+            <a:off x="502920" y="3538728"/>
+            <a:ext cx="11155680" cy="841248"/>
+          </a:xfrm>
+          <a:prstGeom prst="roundRect">
+            <a:avLst>
+              <a:gd name="adj" fmla="val 6000"/>
+            </a:avLst>
+          </a:prstGeom>
+          <a:solidFill>
+            <a:srgbClr val="0E4A3E"/>
+          </a:solidFill>
+          <a:ln>
+            <a:noFill/>
+          </a:ln>
+          <a:effectLst/>
+        </p:spPr>
+        <p:style>
+          <a:lnRef idx="1">
+            <a:schemeClr val="accent1"/>
+          </a:lnRef>
+          <a:fillRef idx="3">
+            <a:schemeClr val="accent1"/>
+          </a:fillRef>
+          <a:effectRef idx="2">
+            <a:schemeClr val="accent1"/>
+          </a:effectRef>
+          <a:fontRef idx="minor">
+            <a:schemeClr val="lt1"/>
+          </a:fontRef>
+        </p:style>
+        <p:txBody>
+          <a:bodyPr rtlCol="0" anchor="ctr"/>
+          <a:lstStyle/>
+          <a:p>
+            <a:pPr algn="ctr"/>
+          </a:p>
+        </p:txBody>
+      </p:sp>
+      <p:sp>
+        <p:nvSpPr>
+          <p:cNvPr id="9" name="TextBox 8"/>
+          <p:cNvSpPr txBox="1"/>
+          <p:nvPr/>
+        </p:nvSpPr>
+        <p:spPr>
+          <a:xfrm>
+            <a:off x="777240" y="3630168"/>
+            <a:ext cx="10607040" cy="676656"/>
+          </a:xfrm>
+          <a:prstGeom prst="rect">
+            <a:avLst/>
+          </a:prstGeom>
+          <a:noFill/>
+        </p:spPr>
+        <p:txBody>
+          <a:bodyPr wrap="square" lIns="0" rIns="0" tIns="0" bIns="0">
+            <a:spAutoFit/>
+          </a:bodyPr>
+          <a:lstStyle/>
+          <a:p>
+            <a:pPr algn="l">
+              <a:spcAft>
+                <a:spcPts val="100"/>
+              </a:spcAft>
+            </a:pPr>
+            <a:r>
+              <a:rPr sz="1350" b="1" i="0">
+                <a:solidFill>
+                  <a:srgbClr val="FFFFFF"/>
+                </a:solidFill>
+                <a:latin typeface="Calibri"/>
+              </a:rPr>
+              <a:t>Corridors cover 41% of clean runs</a:t>
+            </a:r>
+          </a:p>
+          <a:p>
+            <a:pPr algn="l">
+              <a:spcAft>
+                <a:spcPts val="0"/>
+              </a:spcAft>
+            </a:pPr>
+            <a:r>
+              <a:rPr sz="1150" b="0" i="0">
+                <a:solidFill>
+                  <a:srgbClr val="C9E2D8"/>
+                </a:solidFill>
+                <a:latin typeface="Calibri"/>
+              </a:rPr>
+              <a:t>The other 59% was decomposed and shown to be noise, loops and out-of-division traffic — but the corridor findings describe the frequently-driven core only.</a:t>
+            </a:r>
+          </a:p>
+        </p:txBody>
+      </p:sp>
+      <p:sp>
+        <p:nvSpPr>
+          <p:cNvPr id="10" name="Rounded Rectangle 9"/>
+          <p:cNvSpPr/>
+          <p:nvPr/>
+        </p:nvSpPr>
+        <p:spPr>
+          <a:xfrm>
+            <a:off x="502920" y="4507992"/>
+            <a:ext cx="11155680" cy="841248"/>
+          </a:xfrm>
+          <a:prstGeom prst="roundRect">
+            <a:avLst>
+              <a:gd name="adj" fmla="val 6000"/>
+            </a:avLst>
+          </a:prstGeom>
+          <a:solidFill>
+            <a:srgbClr val="0E4A3E"/>
+          </a:solidFill>
+          <a:ln>
+            <a:noFill/>
+          </a:ln>
+          <a:effectLst/>
+        </p:spPr>
+        <p:style>
+          <a:lnRef idx="1">
+            <a:schemeClr val="accent1"/>
+          </a:lnRef>
+          <a:fillRef idx="3">
+            <a:schemeClr val="accent1"/>
+          </a:fillRef>
+          <a:effectRef idx="2">
+            <a:schemeClr val="accent1"/>
+          </a:effectRef>
+          <a:fontRef idx="minor">
+            <a:schemeClr val="lt1"/>
+          </a:fontRef>
+        </p:style>
+        <p:txBody>
+          <a:bodyPr rtlCol="0" anchor="ctr"/>
+          <a:lstStyle/>
+          <a:p>
+            <a:pPr algn="ctr"/>
+          </a:p>
+        </p:txBody>
+      </p:sp>
+      <p:sp>
+        <p:nvSpPr>
+          <p:cNvPr id="11" name="TextBox 10"/>
+          <p:cNvSpPr txBox="1"/>
+          <p:nvPr/>
+        </p:nvSpPr>
+        <p:spPr>
+          <a:xfrm>
+            <a:off x="777240" y="4599431"/>
+            <a:ext cx="10607040" cy="676656"/>
+          </a:xfrm>
+          <a:prstGeom prst="rect">
+            <a:avLst/>
+          </a:prstGeom>
+          <a:noFill/>
+        </p:spPr>
+        <p:txBody>
+          <a:bodyPr wrap="square" lIns="0" rIns="0" tIns="0" bIns="0">
+            <a:spAutoFit/>
+          </a:bodyPr>
+          <a:lstStyle/>
+          <a:p>
+            <a:pPr algn="l">
+              <a:spcAft>
+                <a:spcPts val="100"/>
+              </a:spcAft>
+            </a:pPr>
+            <a:r>
+              <a:rPr sz="1350" b="1" i="0">
+                <a:solidFill>
+                  <a:srgbClr val="FFFFFF"/>
+                </a:solidFill>
+                <a:latin typeface="Calibri"/>
+              </a:rPr>
+              <a:t>Observed times are an upper bound</a:t>
+            </a:r>
+          </a:p>
+          <a:p>
+            <a:pPr algn="l">
+              <a:spcAft>
+                <a:spcPts val="0"/>
+              </a:spcAft>
+            </a:pPr>
+            <a:r>
+              <a:rPr sz="1150" b="0" i="0">
+                <a:solidFill>
+                  <a:srgbClr val="C9E2D8"/>
+                </a:solidFill>
+                <a:latin typeface="Calibri"/>
+              </a:rPr>
+              <a:t>They embody informal wait-to-fill practice; a scheduled, headway-enforced service should beat them.</a:t>
+            </a:r>
+          </a:p>
+        </p:txBody>
+      </p:sp>
+      <p:sp>
+        <p:nvSpPr>
+          <p:cNvPr id="12" name="Rounded Rectangle 11"/>
+          <p:cNvSpPr/>
+          <p:nvPr/>
+        </p:nvSpPr>
+        <p:spPr>
+          <a:xfrm>
+            <a:off x="502920" y="5477256"/>
+            <a:ext cx="11155680" cy="841248"/>
+          </a:xfrm>
+          <a:prstGeom prst="roundRect">
+            <a:avLst>
+              <a:gd name="adj" fmla="val 6000"/>
+            </a:avLst>
+          </a:prstGeom>
+          <a:solidFill>
+            <a:srgbClr val="0E4A3E"/>
+          </a:solidFill>
+          <a:ln>
+            <a:noFill/>
+          </a:ln>
+          <a:effectLst/>
+        </p:spPr>
+        <p:style>
+          <a:lnRef idx="1">
+            <a:schemeClr val="accent1"/>
+          </a:lnRef>
+          <a:fillRef idx="3">
+            <a:schemeClr val="accent1"/>
+          </a:fillRef>
+          <a:effectRef idx="2">
+            <a:schemeClr val="accent1"/>
+          </a:effectRef>
+          <a:fontRef idx="minor">
+            <a:schemeClr val="lt1"/>
+          </a:fontRef>
+        </p:style>
+        <p:txBody>
+          <a:bodyPr rtlCol="0" anchor="ctr"/>
+          <a:lstStyle/>
+          <a:p>
+            <a:pPr algn="ctr"/>
+          </a:p>
+        </p:txBody>
+      </p:sp>
+      <p:sp>
+        <p:nvSpPr>
+          <p:cNvPr id="13" name="TextBox 12"/>
+          <p:cNvSpPr txBox="1"/>
+          <p:nvPr/>
+        </p:nvSpPr>
+        <p:spPr>
+          <a:xfrm>
+            <a:off x="777240" y="5568696"/>
+            <a:ext cx="10607040" cy="676656"/>
+          </a:xfrm>
+          <a:prstGeom prst="rect">
+            <a:avLst/>
+          </a:prstGeom>
+          <a:noFill/>
+        </p:spPr>
+        <p:txBody>
+          <a:bodyPr wrap="square" lIns="0" rIns="0" tIns="0" bIns="0">
+            <a:spAutoFit/>
+          </a:bodyPr>
+          <a:lstStyle/>
+          <a:p>
+            <a:pPr algn="l">
+              <a:spcAft>
+                <a:spcPts val="100"/>
+              </a:spcAft>
+            </a:pPr>
+            <a:r>
+              <a:rPr sz="1350" b="1" i="0">
+                <a:solidFill>
+                  <a:srgbClr val="FFFFFF"/>
+                </a:solidFill>
+                <a:latin typeface="Calibri"/>
+              </a:rPr>
+              <a:t>Rural routes remain unvalidated</a:t>
+            </a:r>
+          </a:p>
+          <a:p>
+            <a:pPr algn="l">
+              <a:spcAft>
+                <a:spcPts val="0"/>
+              </a:spcAft>
+            </a:pPr>
+            <a:r>
+              <a:rPr sz="1150" b="0" i="0">
+                <a:solidFill>
+                  <a:srgbClr val="C9E2D8"/>
+                </a:solidFill>
+                <a:latin typeface="Calibri"/>
+              </a:rPr>
+              <a:t>Measured corrections touch 5 Srinagar-core corridors; long rural lifeline cycle times still rest on the model.</a:t>
+            </a:r>
+          </a:p>
+        </p:txBody>
+      </p:sp>
+    </p:spTree>
+  </p:cSld>
+  <p:clrMapOvr>
+    <a:masterClrMapping/>
+  </p:clrMapOvr>
+</p:sld>
+</file>
+
+<file path=ppt/slides/slide15.xml><?xml version="1.0" encoding="utf-8"?>
 <p:sld xmlns:a="http://schemas.openxmlformats.org/drawingml/2006/main" xmlns:p="http://schemas.openxmlformats.org/presentationml/2006/main" xmlns:r="http://schemas.openxmlformats.org/officeDocument/2006/relationships">
   <p:cSld>
     <p:spTree>

</xml_diff>